<commit_message>
feat(slides): HTML deck export + preview server, block-order fix
- tools/build_slides_html.py → slides/html/*.html (browser decks: arrow keys,
  fullscreen, print/PDF via @page 338×190mm, local Cairo woff2 fonts)
- tools/serve_slides.py → local preview server with correct woff2 MIME types
- build_slides.py: flush pending bullets before a block (content order bug)
- rebuilt PPTX decks + trainer/program docs

Co-authored-by: arena-agent <297053741+arena-agent@users.noreply.github.com>
</commit_message>
<xml_diff>
--- a/slides/s1-intro.pptx
+++ b/slides/s1-intro.pptx
@@ -3490,13 +3490,104 @@
       </p:sp>
       <p:sp>
         <p:nvSpPr>
-          <p:cNvPr id="5" name="Rounded Rectangle 4"/>
+          <p:cNvPr id="5" name="TextBox 4"/>
+          <p:cNvSpPr txBox="1"/>
+          <p:nvPr/>
+        </p:nvSpPr>
+        <p:spPr>
+          <a:xfrm>
+            <a:off x="540000" y="1080000"/>
+            <a:ext cx="11112119" cy="1468120"/>
+          </a:xfrm>
+          <a:prstGeom prst="rect">
+            <a:avLst/>
+          </a:prstGeom>
+          <a:noFill/>
+        </p:spPr>
+        <p:txBody>
+          <a:bodyPr wrap="square" lIns="36000" rIns="36000">
+            <a:spAutoFit/>
+          </a:bodyPr>
+          <a:lstStyle/>
+          <a:p>
+            <a:pPr algn="r" rtl="1">
+              <a:lnSpc>
+                <a:spcPct val="130000"/>
+              </a:lnSpc>
+            </a:pPr>
+            <a:r>
+              <a:rPr sz="1700" b="0">
+                <a:solidFill>
+                  <a:srgbClr val="22303F"/>
+                </a:solidFill>
+                <a:latin typeface="Cairo"/>
+                <a:cs typeface="Cairo"/>
+              </a:rPr>
+              <a:t>• لا نقيّم ما تقوله، بل ما تُنتجه: مخرجات أوامرك الحقيقية من جهازك</a:t>
+            </a:r>
+          </a:p>
+          <a:p>
+            <a:pPr algn="r" rtl="1">
+              <a:lnSpc>
+                <a:spcPct val="130000"/>
+              </a:lnSpc>
+            </a:pPr>
+            <a:r>
+              <a:rPr sz="1700" b="0">
+                <a:solidFill>
+                  <a:srgbClr val="22303F"/>
+                </a:solidFill>
+                <a:latin typeface="Cairo"/>
+                <a:cs typeface="Cairo"/>
+              </a:rPr>
+              <a:t>• كل مهمة فيها صندوق «دليل التسليم» تلصق فيه المخرجات</a:t>
+            </a:r>
+          </a:p>
+          <a:p>
+            <a:pPr algn="r" rtl="1">
+              <a:lnSpc>
+                <a:spcPct val="130000"/>
+              </a:lnSpc>
+            </a:pPr>
+            <a:r>
+              <a:rPr sz="1700" b="0">
+                <a:solidFill>
+                  <a:srgbClr val="22303F"/>
+                </a:solidFill>
+                <a:latin typeface="Cairo"/>
+                <a:cs typeface="Cairo"/>
+              </a:rPr>
+              <a:t>• الأدلة المنسوخة من الورقة تُرفض — نعرفها من رقم الإصدار وأسماء الملفات</a:t>
+            </a:r>
+          </a:p>
+          <a:p>
+            <a:pPr algn="r" rtl="1">
+              <a:lnSpc>
+                <a:spcPct val="130000"/>
+              </a:lnSpc>
+            </a:pPr>
+            <a:r>
+              <a:rPr sz="1700" b="0">
+                <a:solidFill>
+                  <a:srgbClr val="22303F"/>
+                </a:solidFill>
+                <a:latin typeface="Cairo"/>
+                <a:cs typeface="Cairo"/>
+              </a:rPr>
+              <a:t>• إتقان الأمر أهم من سرعة إنجازه</a:t>
+            </a:r>
+          </a:p>
+        </p:txBody>
+      </p:sp>
+      <p:sp>
+        <p:nvSpPr>
+          <p:cNvPr id="6" name="Rounded Rectangle 5"/>
           <p:cNvSpPr/>
           <p:nvPr/>
         </p:nvSpPr>
         <p:spPr>
           <a:xfrm>
-            <a:off x="540000" y="1080000"/>
+            <a:off x="540000" y="2656120"/>
             <a:ext cx="11112119" cy="556799"/>
           </a:xfrm>
           <a:prstGeom prst="roundRect">
@@ -3536,13 +3627,13 @@
       </p:sp>
       <p:sp>
         <p:nvSpPr>
-          <p:cNvPr id="6" name="TextBox 5"/>
+          <p:cNvPr id="7" name="TextBox 6"/>
           <p:cNvSpPr txBox="1"/>
           <p:nvPr/>
         </p:nvSpPr>
         <p:spPr>
           <a:xfrm>
-            <a:off x="665999" y="1188000"/>
+            <a:off x="665999" y="2764120"/>
             <a:ext cx="10860120" cy="376799"/>
           </a:xfrm>
           <a:prstGeom prst="rect">
@@ -3570,97 +3661,6 @@
                 <a:cs typeface="Cairo"/>
               </a:rPr>
               <a:t>معيار إتمام اليوم: حساب مؤمَّن بـ 2FA + Git مهيّأ بالبريد الصحيح + مستودع شخصي فيه التزامك الأول.</a:t>
-            </a:r>
-          </a:p>
-        </p:txBody>
-      </p:sp>
-      <p:sp>
-        <p:nvSpPr>
-          <p:cNvPr id="7" name="TextBox 6"/>
-          <p:cNvSpPr txBox="1"/>
-          <p:nvPr/>
-        </p:nvSpPr>
-        <p:spPr>
-          <a:xfrm>
-            <a:off x="540000" y="1744799"/>
-            <a:ext cx="11112119" cy="1468120"/>
-          </a:xfrm>
-          <a:prstGeom prst="rect">
-            <a:avLst/>
-          </a:prstGeom>
-          <a:noFill/>
-        </p:spPr>
-        <p:txBody>
-          <a:bodyPr wrap="square" lIns="36000" rIns="36000">
-            <a:spAutoFit/>
-          </a:bodyPr>
-          <a:lstStyle/>
-          <a:p>
-            <a:pPr algn="r" rtl="1">
-              <a:lnSpc>
-                <a:spcPct val="130000"/>
-              </a:lnSpc>
-            </a:pPr>
-            <a:r>
-              <a:rPr sz="1700" b="0">
-                <a:solidFill>
-                  <a:srgbClr val="22303F"/>
-                </a:solidFill>
-                <a:latin typeface="Cairo"/>
-                <a:cs typeface="Cairo"/>
-              </a:rPr>
-              <a:t>• لا نقيّم ما تقوله، بل ما تُنتجه: مخرجات أوامرك الحقيقية من جهازك</a:t>
-            </a:r>
-          </a:p>
-          <a:p>
-            <a:pPr algn="r" rtl="1">
-              <a:lnSpc>
-                <a:spcPct val="130000"/>
-              </a:lnSpc>
-            </a:pPr>
-            <a:r>
-              <a:rPr sz="1700" b="0">
-                <a:solidFill>
-                  <a:srgbClr val="22303F"/>
-                </a:solidFill>
-                <a:latin typeface="Cairo"/>
-                <a:cs typeface="Cairo"/>
-              </a:rPr>
-              <a:t>• كل مهمة فيها صندوق «دليل التسليم» تلصق فيه المخرجات</a:t>
-            </a:r>
-          </a:p>
-          <a:p>
-            <a:pPr algn="r" rtl="1">
-              <a:lnSpc>
-                <a:spcPct val="130000"/>
-              </a:lnSpc>
-            </a:pPr>
-            <a:r>
-              <a:rPr sz="1700" b="0">
-                <a:solidFill>
-                  <a:srgbClr val="22303F"/>
-                </a:solidFill>
-                <a:latin typeface="Cairo"/>
-                <a:cs typeface="Cairo"/>
-              </a:rPr>
-              <a:t>• الأدلة المنسوخة من الورقة تُرفض — نعرفها من رقم الإصدار وأسماء الملفات</a:t>
-            </a:r>
-          </a:p>
-          <a:p>
-            <a:pPr algn="r" rtl="1">
-              <a:lnSpc>
-                <a:spcPct val="130000"/>
-              </a:lnSpc>
-            </a:pPr>
-            <a:r>
-              <a:rPr sz="1700" b="0">
-                <a:solidFill>
-                  <a:srgbClr val="22303F"/>
-                </a:solidFill>
-                <a:latin typeface="Cairo"/>
-                <a:cs typeface="Cairo"/>
-              </a:rPr>
-              <a:t>• إتقان الأمر أهم من سرعة إنجازه</a:t>
             </a:r>
           </a:p>
         </p:txBody>
@@ -3809,13 +3809,164 @@
       </p:sp>
       <p:sp>
         <p:nvSpPr>
-          <p:cNvPr id="5" name="Rounded Rectangle 4"/>
+          <p:cNvPr id="5" name="TextBox 4"/>
+          <p:cNvSpPr txBox="1"/>
+          <p:nvPr/>
+        </p:nvSpPr>
+        <p:spPr>
+          <a:xfrm>
+            <a:off x="540000" y="1080000"/>
+            <a:ext cx="11112119" cy="1468120"/>
+          </a:xfrm>
+          <a:prstGeom prst="rect">
+            <a:avLst/>
+          </a:prstGeom>
+          <a:noFill/>
+        </p:spPr>
+        <p:txBody>
+          <a:bodyPr wrap="square" lIns="36000" rIns="36000">
+            <a:spAutoFit/>
+          </a:bodyPr>
+          <a:lstStyle/>
+          <a:p>
+            <a:pPr algn="r" rtl="1">
+              <a:lnSpc>
+                <a:spcPct val="130000"/>
+              </a:lnSpc>
+            </a:pPr>
+            <a:r>
+              <a:rPr sz="1700" b="0">
+                <a:solidFill>
+                  <a:srgbClr val="22303F"/>
+                </a:solidFill>
+                <a:latin typeface="Cairo"/>
+                <a:cs typeface="Cairo"/>
+              </a:rPr>
+              <a:t>• أكملت المهام 1–6 وملأت الأدلة في ورقة العمل 01</a:t>
+            </a:r>
+          </a:p>
+          <a:p>
+            <a:pPr algn="r" rtl="1">
+              <a:lnSpc>
+                <a:spcPct val="130000"/>
+              </a:lnSpc>
+            </a:pPr>
+            <a:r>
+              <a:rPr sz="1700" b="0">
+                <a:solidFill>
+                  <a:srgbClr val="22303F"/>
+                </a:solidFill>
+                <a:latin typeface="Cairo"/>
+                <a:cs typeface="Cairo"/>
+              </a:rPr>
+              <a:t>• تأكد: </a:t>
+            </a:r>
+            <a:r>
+              <a:rPr sz="1700" b="0">
+                <a:solidFill>
+                  <a:srgbClr val="22303F"/>
+                </a:solidFill>
+                <a:latin typeface="Consolas"/>
+                <a:cs typeface="Consolas"/>
+              </a:rPr>
+              <a:t>git config --list</a:t>
+            </a:r>
+            <a:r>
+              <a:rPr sz="1700" b="0">
+                <a:solidFill>
+                  <a:srgbClr val="22303F"/>
+                </a:solidFill>
+                <a:latin typeface="Cairo"/>
+                <a:cs typeface="Cairo"/>
+              </a:rPr>
+              <a:t> يُظهر بريدك الصحيح</a:t>
+            </a:r>
+          </a:p>
+          <a:p>
+            <a:pPr algn="r" rtl="1">
+              <a:lnSpc>
+                <a:spcPct val="130000"/>
+              </a:lnSpc>
+            </a:pPr>
+            <a:r>
+              <a:rPr sz="1700" b="0">
+                <a:solidFill>
+                  <a:srgbClr val="22303F"/>
+                </a:solidFill>
+                <a:latin typeface="Cairo"/>
+                <a:cs typeface="Cairo"/>
+              </a:rPr>
+              <a:t>• تأكد: </a:t>
+            </a:r>
+            <a:r>
+              <a:rPr sz="1700" b="0">
+                <a:solidFill>
+                  <a:srgbClr val="22303F"/>
+                </a:solidFill>
+                <a:latin typeface="Consolas"/>
+                <a:cs typeface="Consolas"/>
+              </a:rPr>
+              <a:t>git log --oneline</a:t>
+            </a:r>
+            <a:r>
+              <a:rPr sz="1700" b="0">
+                <a:solidFill>
+                  <a:srgbClr val="22303F"/>
+                </a:solidFill>
+                <a:latin typeface="Cairo"/>
+                <a:cs typeface="Cairo"/>
+              </a:rPr>
+              <a:t> في مستودعك يُظهر التزامك</a:t>
+            </a:r>
+          </a:p>
+          <a:p>
+            <a:pPr algn="r" rtl="1">
+              <a:lnSpc>
+                <a:spcPct val="130000"/>
+              </a:lnSpc>
+            </a:pPr>
+            <a:r>
+              <a:rPr sz="1700" b="0">
+                <a:solidFill>
+                  <a:srgbClr val="22303F"/>
+                </a:solidFill>
+                <a:latin typeface="Cairo"/>
+                <a:cs typeface="Cairo"/>
+              </a:rPr>
+              <a:t>• الجلسة القادمة: سنستنسخ </a:t>
+            </a:r>
+            <a:r>
+              <a:rPr sz="1700" b="1">
+                <a:solidFill>
+                  <a:srgbClr val="22303F"/>
+                </a:solidFill>
+                <a:latin typeface="Cairo"/>
+                <a:cs typeface="Cairo"/>
+              </a:rPr>
+              <a:t>مستودع الفريق</a:t>
+            </a:r>
+            <a:r>
+              <a:rPr sz="1700" b="0">
+                <a:solidFill>
+                  <a:srgbClr val="22303F"/>
+                </a:solidFill>
+                <a:latin typeface="Cairo"/>
+                <a:cs typeface="Cairo"/>
+              </a:rPr>
+              <a:t> ونشغّل الموقع على أجهزتنا</a:t>
+            </a:r>
+          </a:p>
+        </p:txBody>
+      </p:sp>
+      <p:sp>
+        <p:nvSpPr>
+          <p:cNvPr id="6" name="Rounded Rectangle 5"/>
           <p:cNvSpPr/>
           <p:nvPr/>
         </p:nvSpPr>
         <p:spPr>
           <a:xfrm>
-            <a:off x="540000" y="1080000"/>
+            <a:off x="540000" y="2656120"/>
             <a:ext cx="11112119" cy="556799"/>
           </a:xfrm>
           <a:prstGeom prst="roundRect">
@@ -3855,13 +4006,13 @@
       </p:sp>
       <p:sp>
         <p:nvSpPr>
-          <p:cNvPr id="6" name="TextBox 5"/>
+          <p:cNvPr id="7" name="TextBox 6"/>
           <p:cNvSpPr txBox="1"/>
           <p:nvPr/>
         </p:nvSpPr>
         <p:spPr>
           <a:xfrm>
-            <a:off x="665999" y="1188000"/>
+            <a:off x="665999" y="2764120"/>
             <a:ext cx="10860120" cy="376799"/>
           </a:xfrm>
           <a:prstGeom prst="rect">
@@ -3909,157 +4060,6 @@
                 <a:cs typeface="Cairo"/>
               </a:rPr>
               <a:t> وحدها لرفع عملك إلى GitHub؟ ستجد الجواب في أول دقيقة من الجلسة القادمة.</a:t>
-            </a:r>
-          </a:p>
-        </p:txBody>
-      </p:sp>
-      <p:sp>
-        <p:nvSpPr>
-          <p:cNvPr id="7" name="TextBox 6"/>
-          <p:cNvSpPr txBox="1"/>
-          <p:nvPr/>
-        </p:nvSpPr>
-        <p:spPr>
-          <a:xfrm>
-            <a:off x="540000" y="1744799"/>
-            <a:ext cx="11112119" cy="1468120"/>
-          </a:xfrm>
-          <a:prstGeom prst="rect">
-            <a:avLst/>
-          </a:prstGeom>
-          <a:noFill/>
-        </p:spPr>
-        <p:txBody>
-          <a:bodyPr wrap="square" lIns="36000" rIns="36000">
-            <a:spAutoFit/>
-          </a:bodyPr>
-          <a:lstStyle/>
-          <a:p>
-            <a:pPr algn="r" rtl="1">
-              <a:lnSpc>
-                <a:spcPct val="130000"/>
-              </a:lnSpc>
-            </a:pPr>
-            <a:r>
-              <a:rPr sz="1700" b="0">
-                <a:solidFill>
-                  <a:srgbClr val="22303F"/>
-                </a:solidFill>
-                <a:latin typeface="Cairo"/>
-                <a:cs typeface="Cairo"/>
-              </a:rPr>
-              <a:t>• أكملت المهام 1–6 وملأت الأدلة في ورقة العمل 01</a:t>
-            </a:r>
-          </a:p>
-          <a:p>
-            <a:pPr algn="r" rtl="1">
-              <a:lnSpc>
-                <a:spcPct val="130000"/>
-              </a:lnSpc>
-            </a:pPr>
-            <a:r>
-              <a:rPr sz="1700" b="0">
-                <a:solidFill>
-                  <a:srgbClr val="22303F"/>
-                </a:solidFill>
-                <a:latin typeface="Cairo"/>
-                <a:cs typeface="Cairo"/>
-              </a:rPr>
-              <a:t>• تأكد: </a:t>
-            </a:r>
-            <a:r>
-              <a:rPr sz="1700" b="0">
-                <a:solidFill>
-                  <a:srgbClr val="22303F"/>
-                </a:solidFill>
-                <a:latin typeface="Consolas"/>
-                <a:cs typeface="Consolas"/>
-              </a:rPr>
-              <a:t>git config --list</a:t>
-            </a:r>
-            <a:r>
-              <a:rPr sz="1700" b="0">
-                <a:solidFill>
-                  <a:srgbClr val="22303F"/>
-                </a:solidFill>
-                <a:latin typeface="Cairo"/>
-                <a:cs typeface="Cairo"/>
-              </a:rPr>
-              <a:t> يُظهر بريدك الصحيح</a:t>
-            </a:r>
-          </a:p>
-          <a:p>
-            <a:pPr algn="r" rtl="1">
-              <a:lnSpc>
-                <a:spcPct val="130000"/>
-              </a:lnSpc>
-            </a:pPr>
-            <a:r>
-              <a:rPr sz="1700" b="0">
-                <a:solidFill>
-                  <a:srgbClr val="22303F"/>
-                </a:solidFill>
-                <a:latin typeface="Cairo"/>
-                <a:cs typeface="Cairo"/>
-              </a:rPr>
-              <a:t>• تأكد: </a:t>
-            </a:r>
-            <a:r>
-              <a:rPr sz="1700" b="0">
-                <a:solidFill>
-                  <a:srgbClr val="22303F"/>
-                </a:solidFill>
-                <a:latin typeface="Consolas"/>
-                <a:cs typeface="Consolas"/>
-              </a:rPr>
-              <a:t>git log --oneline</a:t>
-            </a:r>
-            <a:r>
-              <a:rPr sz="1700" b="0">
-                <a:solidFill>
-                  <a:srgbClr val="22303F"/>
-                </a:solidFill>
-                <a:latin typeface="Cairo"/>
-                <a:cs typeface="Cairo"/>
-              </a:rPr>
-              <a:t> في مستودعك يُظهر التزامك</a:t>
-            </a:r>
-          </a:p>
-          <a:p>
-            <a:pPr algn="r" rtl="1">
-              <a:lnSpc>
-                <a:spcPct val="130000"/>
-              </a:lnSpc>
-            </a:pPr>
-            <a:r>
-              <a:rPr sz="1700" b="0">
-                <a:solidFill>
-                  <a:srgbClr val="22303F"/>
-                </a:solidFill>
-                <a:latin typeface="Cairo"/>
-                <a:cs typeface="Cairo"/>
-              </a:rPr>
-              <a:t>• الجلسة القادمة: سنستنسخ </a:t>
-            </a:r>
-            <a:r>
-              <a:rPr sz="1700" b="1">
-                <a:solidFill>
-                  <a:srgbClr val="22303F"/>
-                </a:solidFill>
-                <a:latin typeface="Cairo"/>
-                <a:cs typeface="Cairo"/>
-              </a:rPr>
-              <a:t>مستودع الفريق</a:t>
-            </a:r>
-            <a:r>
-              <a:rPr sz="1700" b="0">
-                <a:solidFill>
-                  <a:srgbClr val="22303F"/>
-                </a:solidFill>
-                <a:latin typeface="Cairo"/>
-                <a:cs typeface="Cairo"/>
-              </a:rPr>
-              <a:t> ونشغّل الموقع على أجهزتنا</a:t>
             </a:r>
           </a:p>
         </p:txBody>
@@ -4208,13 +4208,104 @@
       </p:sp>
       <p:sp>
         <p:nvSpPr>
-          <p:cNvPr id="5" name="Rounded Rectangle 4"/>
+          <p:cNvPr id="5" name="TextBox 4"/>
+          <p:cNvSpPr txBox="1"/>
+          <p:nvPr/>
+        </p:nvSpPr>
+        <p:spPr>
+          <a:xfrm>
+            <a:off x="540000" y="1080000"/>
+            <a:ext cx="11112119" cy="1468120"/>
+          </a:xfrm>
+          <a:prstGeom prst="rect">
+            <a:avLst/>
+          </a:prstGeom>
+          <a:noFill/>
+        </p:spPr>
+        <p:txBody>
+          <a:bodyPr wrap="square" lIns="36000" rIns="36000">
+            <a:spAutoFit/>
+          </a:bodyPr>
+          <a:lstStyle/>
+          <a:p>
+            <a:pPr algn="r" rtl="1">
+              <a:lnSpc>
+                <a:spcPct val="130000"/>
+              </a:lnSpc>
+            </a:pPr>
+            <a:r>
+              <a:rPr sz="1700" b="0">
+                <a:solidFill>
+                  <a:srgbClr val="22303F"/>
+                </a:solidFill>
+                <a:latin typeface="Cairo"/>
+                <a:cs typeface="Cairo"/>
+              </a:rPr>
+              <a:t>• موقع ويب حقيقي على الإنترنت اسمه «دليل فريق الصف»</a:t>
+            </a:r>
+          </a:p>
+          <a:p>
+            <a:pPr algn="r" rtl="1">
+              <a:lnSpc>
+                <a:spcPct val="130000"/>
+              </a:lnSpc>
+            </a:pPr>
+            <a:r>
+              <a:rPr sz="1700" b="0">
+                <a:solidFill>
+                  <a:srgbClr val="22303F"/>
+                </a:solidFill>
+                <a:latin typeface="Cairo"/>
+                <a:cs typeface="Cairo"/>
+              </a:rPr>
+              <a:t>• كل طالب يضيف بطاقة تعريفية له بنفسه</a:t>
+            </a:r>
+          </a:p>
+          <a:p>
+            <a:pPr algn="r" rtl="1">
+              <a:lnSpc>
+                <a:spcPct val="130000"/>
+              </a:lnSpc>
+            </a:pPr>
+            <a:r>
+              <a:rPr sz="1700" b="0">
+                <a:solidFill>
+                  <a:srgbClr val="22303F"/>
+                </a:solidFill>
+                <a:latin typeface="Cairo"/>
+                <a:cs typeface="Cairo"/>
+              </a:rPr>
+              <a:t>• نرى البطاقات تتراكم واحداً بعد آخر حتى يصبح الموقع لوحة كاملة للفريق</a:t>
+            </a:r>
+          </a:p>
+          <a:p>
+            <a:pPr algn="r" rtl="1">
+              <a:lnSpc>
+                <a:spcPct val="130000"/>
+              </a:lnSpc>
+            </a:pPr>
+            <a:r>
+              <a:rPr sz="1700" b="0">
+                <a:solidFill>
+                  <a:srgbClr val="22303F"/>
+                </a:solidFill>
+                <a:latin typeface="Cairo"/>
+                <a:cs typeface="Cairo"/>
+              </a:rPr>
+              <a:t>• النهاية: رابط عام يفتحه أي شخص ويرى فيه اسمك ودورك</a:t>
+            </a:r>
+          </a:p>
+        </p:txBody>
+      </p:sp>
+      <p:sp>
+        <p:nvSpPr>
+          <p:cNvPr id="6" name="Rounded Rectangle 5"/>
           <p:cNvSpPr/>
           <p:nvPr/>
         </p:nvSpPr>
         <p:spPr>
           <a:xfrm>
-            <a:off x="540000" y="1080000"/>
+            <a:off x="540000" y="2656120"/>
             <a:ext cx="11112119" cy="556799"/>
           </a:xfrm>
           <a:prstGeom prst="roundRect">
@@ -4254,13 +4345,13 @@
       </p:sp>
       <p:sp>
         <p:nvSpPr>
-          <p:cNvPr id="6" name="TextBox 5"/>
+          <p:cNvPr id="7" name="TextBox 6"/>
           <p:cNvSpPr txBox="1"/>
           <p:nvPr/>
         </p:nvSpPr>
         <p:spPr>
           <a:xfrm>
-            <a:off x="665999" y="1188000"/>
+            <a:off x="665999" y="2764120"/>
             <a:ext cx="10860120" cy="376799"/>
           </a:xfrm>
           <a:prstGeom prst="rect">
@@ -4288,97 +4379,6 @@
                 <a:cs typeface="Cairo"/>
               </a:rPr>
               <a:t>البرنامج كله مبني على مشروع واحد: تتعلم Git لأنك تحتاجه فعلاً، لا لأن هناك واجباً.</a:t>
-            </a:r>
-          </a:p>
-        </p:txBody>
-      </p:sp>
-      <p:sp>
-        <p:nvSpPr>
-          <p:cNvPr id="7" name="TextBox 6"/>
-          <p:cNvSpPr txBox="1"/>
-          <p:nvPr/>
-        </p:nvSpPr>
-        <p:spPr>
-          <a:xfrm>
-            <a:off x="540000" y="1744799"/>
-            <a:ext cx="11112119" cy="1468120"/>
-          </a:xfrm>
-          <a:prstGeom prst="rect">
-            <a:avLst/>
-          </a:prstGeom>
-          <a:noFill/>
-        </p:spPr>
-        <p:txBody>
-          <a:bodyPr wrap="square" lIns="36000" rIns="36000">
-            <a:spAutoFit/>
-          </a:bodyPr>
-          <a:lstStyle/>
-          <a:p>
-            <a:pPr algn="r" rtl="1">
-              <a:lnSpc>
-                <a:spcPct val="130000"/>
-              </a:lnSpc>
-            </a:pPr>
-            <a:r>
-              <a:rPr sz="1700" b="0">
-                <a:solidFill>
-                  <a:srgbClr val="22303F"/>
-                </a:solidFill>
-                <a:latin typeface="Cairo"/>
-                <a:cs typeface="Cairo"/>
-              </a:rPr>
-              <a:t>• موقع ويب حقيقي على الإنترنت اسمه «دليل فريق الصف»</a:t>
-            </a:r>
-          </a:p>
-          <a:p>
-            <a:pPr algn="r" rtl="1">
-              <a:lnSpc>
-                <a:spcPct val="130000"/>
-              </a:lnSpc>
-            </a:pPr>
-            <a:r>
-              <a:rPr sz="1700" b="0">
-                <a:solidFill>
-                  <a:srgbClr val="22303F"/>
-                </a:solidFill>
-                <a:latin typeface="Cairo"/>
-                <a:cs typeface="Cairo"/>
-              </a:rPr>
-              <a:t>• كل طالب يضيف بطاقة تعريفية له بنفسه</a:t>
-            </a:r>
-          </a:p>
-          <a:p>
-            <a:pPr algn="r" rtl="1">
-              <a:lnSpc>
-                <a:spcPct val="130000"/>
-              </a:lnSpc>
-            </a:pPr>
-            <a:r>
-              <a:rPr sz="1700" b="0">
-                <a:solidFill>
-                  <a:srgbClr val="22303F"/>
-                </a:solidFill>
-                <a:latin typeface="Cairo"/>
-                <a:cs typeface="Cairo"/>
-              </a:rPr>
-              <a:t>• نرى البطاقات تتراكم واحداً بعد آخر حتى يصبح الموقع لوحة كاملة للفريق</a:t>
-            </a:r>
-          </a:p>
-          <a:p>
-            <a:pPr algn="r" rtl="1">
-              <a:lnSpc>
-                <a:spcPct val="130000"/>
-              </a:lnSpc>
-            </a:pPr>
-            <a:r>
-              <a:rPr sz="1700" b="0">
-                <a:solidFill>
-                  <a:srgbClr val="22303F"/>
-                </a:solidFill>
-                <a:latin typeface="Cairo"/>
-                <a:cs typeface="Cairo"/>
-              </a:rPr>
-              <a:t>• النهاية: رابط عام يفتحه أي شخص ويرى فيه اسمك ودورك</a:t>
             </a:r>
           </a:p>
         </p:txBody>
@@ -4693,13 +4693,124 @@
       </p:sp>
       <p:sp>
         <p:nvSpPr>
-          <p:cNvPr id="5" name="Rounded Rectangle 4"/>
+          <p:cNvPr id="5" name="TextBox 4"/>
+          <p:cNvSpPr txBox="1"/>
+          <p:nvPr/>
+        </p:nvSpPr>
+        <p:spPr>
+          <a:xfrm>
+            <a:off x="540000" y="1080000"/>
+            <a:ext cx="11112119" cy="1468120"/>
+          </a:xfrm>
+          <a:prstGeom prst="rect">
+            <a:avLst/>
+          </a:prstGeom>
+          <a:noFill/>
+        </p:spPr>
+        <p:txBody>
+          <a:bodyPr wrap="square" lIns="36000" rIns="36000">
+            <a:spAutoFit/>
+          </a:bodyPr>
+          <a:lstStyle/>
+          <a:p>
+            <a:pPr algn="r" rtl="1">
+              <a:lnSpc>
+                <a:spcPct val="130000"/>
+              </a:lnSpc>
+            </a:pPr>
+            <a:r>
+              <a:rPr sz="1700" b="0">
+                <a:solidFill>
+                  <a:srgbClr val="22303F"/>
+                </a:solidFill>
+                <a:latin typeface="Cairo"/>
+                <a:cs typeface="Cairo"/>
+              </a:rPr>
+              <a:t>• Git هو المحرّك: برنامج على جهازك يسجّل التغييرات ويدير الفروع</a:t>
+            </a:r>
+          </a:p>
+          <a:p>
+            <a:pPr algn="r" rtl="1">
+              <a:lnSpc>
+                <a:spcPct val="130000"/>
+              </a:lnSpc>
+            </a:pPr>
+            <a:r>
+              <a:rPr sz="1700" b="0">
+                <a:solidFill>
+                  <a:srgbClr val="22303F"/>
+                </a:solidFill>
+                <a:latin typeface="Cairo"/>
+                <a:cs typeface="Cairo"/>
+              </a:rPr>
+              <a:t>• GitHub هو المكان: خدمة على الإنترنت يستضيف المستودعات ويضيف التعاون</a:t>
+            </a:r>
+          </a:p>
+          <a:p>
+            <a:pPr algn="r" rtl="1">
+              <a:lnSpc>
+                <a:spcPct val="130000"/>
+              </a:lnSpc>
+            </a:pPr>
+            <a:r>
+              <a:rPr sz="1700" b="0">
+                <a:solidFill>
+                  <a:srgbClr val="22303F"/>
+                </a:solidFill>
+                <a:latin typeface="Cairo"/>
+                <a:cs typeface="Cairo"/>
+              </a:rPr>
+              <a:t>• لا يعمل أحدهما بدل الآخر: بدون Git لا تعمل من الطرفية، وبدون GitHub لا يعمل الفريق معاً</a:t>
+            </a:r>
+          </a:p>
+          <a:p>
+            <a:pPr algn="r" rtl="1">
+              <a:lnSpc>
+                <a:spcPct val="130000"/>
+              </a:lnSpc>
+            </a:pPr>
+            <a:r>
+              <a:rPr sz="1700" b="0">
+                <a:solidFill>
+                  <a:srgbClr val="22303F"/>
+                </a:solidFill>
+                <a:latin typeface="Cairo"/>
+                <a:cs typeface="Cairo"/>
+              </a:rPr>
+              <a:t>• سؤال سريع: الأمر </a:t>
+            </a:r>
+            <a:r>
+              <a:rPr sz="1700" b="0">
+                <a:solidFill>
+                  <a:srgbClr val="22303F"/>
+                </a:solidFill>
+                <a:latin typeface="Consolas"/>
+                <a:cs typeface="Consolas"/>
+              </a:rPr>
+              <a:t>git status</a:t>
+            </a:r>
+            <a:r>
+              <a:rPr sz="1700" b="0">
+                <a:solidFill>
+                  <a:srgbClr val="22303F"/>
+                </a:solidFill>
+                <a:latin typeface="Cairo"/>
+                <a:cs typeface="Cairo"/>
+              </a:rPr>
+              <a:t> أين يعمل؟ — على جهازك</a:t>
+            </a:r>
+          </a:p>
+        </p:txBody>
+      </p:sp>
+      <p:sp>
+        <p:nvSpPr>
+          <p:cNvPr id="6" name="Rounded Rectangle 5"/>
           <p:cNvSpPr/>
           <p:nvPr/>
         </p:nvSpPr>
         <p:spPr>
           <a:xfrm>
-            <a:off x="540000" y="1080000"/>
+            <a:off x="540000" y="2656120"/>
             <a:ext cx="11112119" cy="556799"/>
           </a:xfrm>
           <a:prstGeom prst="roundRect">
@@ -4739,13 +4850,13 @@
       </p:sp>
       <p:sp>
         <p:nvSpPr>
-          <p:cNvPr id="6" name="TextBox 5"/>
+          <p:cNvPr id="7" name="TextBox 6"/>
           <p:cNvSpPr txBox="1"/>
           <p:nvPr/>
         </p:nvSpPr>
         <p:spPr>
           <a:xfrm>
-            <a:off x="665999" y="1188000"/>
+            <a:off x="665999" y="2764120"/>
             <a:ext cx="10860120" cy="376799"/>
           </a:xfrm>
           <a:prstGeom prst="rect">
@@ -4813,117 +4924,6 @@
                 <a:cs typeface="Cairo"/>
               </a:rPr>
               <a:t>؟ (الجواب: الثاني فقط)</a:t>
-            </a:r>
-          </a:p>
-        </p:txBody>
-      </p:sp>
-      <p:sp>
-        <p:nvSpPr>
-          <p:cNvPr id="7" name="TextBox 6"/>
-          <p:cNvSpPr txBox="1"/>
-          <p:nvPr/>
-        </p:nvSpPr>
-        <p:spPr>
-          <a:xfrm>
-            <a:off x="540000" y="1744799"/>
-            <a:ext cx="11112119" cy="1468120"/>
-          </a:xfrm>
-          <a:prstGeom prst="rect">
-            <a:avLst/>
-          </a:prstGeom>
-          <a:noFill/>
-        </p:spPr>
-        <p:txBody>
-          <a:bodyPr wrap="square" lIns="36000" rIns="36000">
-            <a:spAutoFit/>
-          </a:bodyPr>
-          <a:lstStyle/>
-          <a:p>
-            <a:pPr algn="r" rtl="1">
-              <a:lnSpc>
-                <a:spcPct val="130000"/>
-              </a:lnSpc>
-            </a:pPr>
-            <a:r>
-              <a:rPr sz="1700" b="0">
-                <a:solidFill>
-                  <a:srgbClr val="22303F"/>
-                </a:solidFill>
-                <a:latin typeface="Cairo"/>
-                <a:cs typeface="Cairo"/>
-              </a:rPr>
-              <a:t>• Git هو المحرّك: برنامج على جهازك يسجّل التغييرات ويدير الفروع</a:t>
-            </a:r>
-          </a:p>
-          <a:p>
-            <a:pPr algn="r" rtl="1">
-              <a:lnSpc>
-                <a:spcPct val="130000"/>
-              </a:lnSpc>
-            </a:pPr>
-            <a:r>
-              <a:rPr sz="1700" b="0">
-                <a:solidFill>
-                  <a:srgbClr val="22303F"/>
-                </a:solidFill>
-                <a:latin typeface="Cairo"/>
-                <a:cs typeface="Cairo"/>
-              </a:rPr>
-              <a:t>• GitHub هو المكان: خدمة على الإنترنت يستضيف المستودعات ويضيف التعاون</a:t>
-            </a:r>
-          </a:p>
-          <a:p>
-            <a:pPr algn="r" rtl="1">
-              <a:lnSpc>
-                <a:spcPct val="130000"/>
-              </a:lnSpc>
-            </a:pPr>
-            <a:r>
-              <a:rPr sz="1700" b="0">
-                <a:solidFill>
-                  <a:srgbClr val="22303F"/>
-                </a:solidFill>
-                <a:latin typeface="Cairo"/>
-                <a:cs typeface="Cairo"/>
-              </a:rPr>
-              <a:t>• لا يعمل أحدهما بدل الآخر: بدون Git لا تعمل من الطرفية، وبدون GitHub لا يعمل الفريق معاً</a:t>
-            </a:r>
-          </a:p>
-          <a:p>
-            <a:pPr algn="r" rtl="1">
-              <a:lnSpc>
-                <a:spcPct val="130000"/>
-              </a:lnSpc>
-            </a:pPr>
-            <a:r>
-              <a:rPr sz="1700" b="0">
-                <a:solidFill>
-                  <a:srgbClr val="22303F"/>
-                </a:solidFill>
-                <a:latin typeface="Cairo"/>
-                <a:cs typeface="Cairo"/>
-              </a:rPr>
-              <a:t>• سؤال سريع: الأمر </a:t>
-            </a:r>
-            <a:r>
-              <a:rPr sz="1700" b="0">
-                <a:solidFill>
-                  <a:srgbClr val="22303F"/>
-                </a:solidFill>
-                <a:latin typeface="Consolas"/>
-                <a:cs typeface="Consolas"/>
-              </a:rPr>
-              <a:t>git status</a:t>
-            </a:r>
-            <a:r>
-              <a:rPr sz="1700" b="0">
-                <a:solidFill>
-                  <a:srgbClr val="22303F"/>
-                </a:solidFill>
-                <a:latin typeface="Cairo"/>
-                <a:cs typeface="Cairo"/>
-              </a:rPr>
-              <a:t> أين يعمل؟ — على جهازك</a:t>
             </a:r>
           </a:p>
         </p:txBody>
@@ -5937,13 +5937,138 @@
       </p:sp>
       <p:sp>
         <p:nvSpPr>
-          <p:cNvPr id="5" name="Rounded Rectangle 4"/>
+          <p:cNvPr id="5" name="TextBox 4"/>
+          <p:cNvSpPr txBox="1"/>
+          <p:nvPr/>
+        </p:nvSpPr>
+        <p:spPr>
+          <a:xfrm>
+            <a:off x="540000" y="1080000"/>
+            <a:ext cx="11112119" cy="2202180"/>
+          </a:xfrm>
+          <a:prstGeom prst="rect">
+            <a:avLst/>
+          </a:prstGeom>
+          <a:noFill/>
+        </p:spPr>
+        <p:txBody>
+          <a:bodyPr wrap="square" lIns="36000" rIns="36000">
+            <a:spAutoFit/>
+          </a:bodyPr>
+          <a:lstStyle/>
+          <a:p>
+            <a:pPr algn="r" rtl="1">
+              <a:lnSpc>
+                <a:spcPct val="130000"/>
+              </a:lnSpc>
+            </a:pPr>
+            <a:r>
+              <a:rPr sz="1700" b="0">
+                <a:solidFill>
+                  <a:srgbClr val="22303F"/>
+                </a:solidFill>
+                <a:latin typeface="Cairo"/>
+                <a:cs typeface="Cairo"/>
+              </a:rPr>
+              <a:t>• المهمة 1: تثبيت Git والتحقق منه</a:t>
+            </a:r>
+          </a:p>
+          <a:p>
+            <a:pPr algn="r" rtl="1">
+              <a:lnSpc>
+                <a:spcPct val="130000"/>
+              </a:lnSpc>
+            </a:pPr>
+            <a:r>
+              <a:rPr sz="1700" b="0">
+                <a:solidFill>
+                  <a:srgbClr val="22303F"/>
+                </a:solidFill>
+                <a:latin typeface="Cairo"/>
+                <a:cs typeface="Cairo"/>
+              </a:rPr>
+              <a:t>• المهمة 2: ضبط الهوية (الاسم والبريد) — أهم خطوة في الورقة</a:t>
+            </a:r>
+          </a:p>
+          <a:p>
+            <a:pPr algn="r" rtl="1">
+              <a:lnSpc>
+                <a:spcPct val="130000"/>
+              </a:lnSpc>
+            </a:pPr>
+            <a:r>
+              <a:rPr sz="1700" b="0">
+                <a:solidFill>
+                  <a:srgbClr val="22303F"/>
+                </a:solidFill>
+                <a:latin typeface="Cairo"/>
+                <a:cs typeface="Cairo"/>
+              </a:rPr>
+              <a:t>• المهمة 3: إنشاء حساب GitHub مهني + التحقق بخطوتين</a:t>
+            </a:r>
+          </a:p>
+          <a:p>
+            <a:pPr algn="r" rtl="1">
+              <a:lnSpc>
+                <a:spcPct val="130000"/>
+              </a:lnSpc>
+            </a:pPr>
+            <a:r>
+              <a:rPr sz="1700" b="0">
+                <a:solidFill>
+                  <a:srgbClr val="22303F"/>
+                </a:solidFill>
+                <a:latin typeface="Cairo"/>
+                <a:cs typeface="Cairo"/>
+              </a:rPr>
+              <a:t>• المهمة 4: مفتاح SSH أو رمز وصول شخصي (PAT)</a:t>
+            </a:r>
+          </a:p>
+          <a:p>
+            <a:pPr algn="r" rtl="1">
+              <a:lnSpc>
+                <a:spcPct val="130000"/>
+              </a:lnSpc>
+            </a:pPr>
+            <a:r>
+              <a:rPr sz="1700" b="0">
+                <a:solidFill>
+                  <a:srgbClr val="22303F"/>
+                </a:solidFill>
+                <a:latin typeface="Cairo"/>
+                <a:cs typeface="Cairo"/>
+              </a:rPr>
+              <a:t>• المهمة 5: تجهيز VS Code والطرفية</a:t>
+            </a:r>
+          </a:p>
+          <a:p>
+            <a:pPr algn="r" rtl="1">
+              <a:lnSpc>
+                <a:spcPct val="130000"/>
+              </a:lnSpc>
+            </a:pPr>
+            <a:r>
+              <a:rPr sz="1700" b="0">
+                <a:solidFill>
+                  <a:srgbClr val="22303F"/>
+                </a:solidFill>
+                <a:latin typeface="Cairo"/>
+                <a:cs typeface="Cairo"/>
+              </a:rPr>
+              <a:t>• المهمة 6: أول مستودع شخصي: clone ثم commit ثم push</a:t>
+            </a:r>
+          </a:p>
+        </p:txBody>
+      </p:sp>
+      <p:sp>
+        <p:nvSpPr>
+          <p:cNvPr id="6" name="Rounded Rectangle 5"/>
           <p:cNvSpPr/>
           <p:nvPr/>
         </p:nvSpPr>
         <p:spPr>
           <a:xfrm>
-            <a:off x="540000" y="1080000"/>
+            <a:off x="540000" y="3390180"/>
             <a:ext cx="11112119" cy="556799"/>
           </a:xfrm>
           <a:prstGeom prst="roundRect">
@@ -5983,13 +6108,13 @@
       </p:sp>
       <p:sp>
         <p:nvSpPr>
-          <p:cNvPr id="6" name="TextBox 5"/>
+          <p:cNvPr id="7" name="TextBox 6"/>
           <p:cNvSpPr txBox="1"/>
           <p:nvPr/>
         </p:nvSpPr>
         <p:spPr>
           <a:xfrm>
-            <a:off x="665999" y="1188000"/>
+            <a:off x="665999" y="3498180"/>
             <a:ext cx="10860120" cy="376799"/>
           </a:xfrm>
           <a:prstGeom prst="rect">
@@ -6017,131 +6142,6 @@
                 <a:cs typeface="Cairo"/>
               </a:rPr>
               <a:t>القاعدة الذهبية: اكتب الأوامر بيدك، ولا تخف من الخطأ — كل خطأ هنا يمكن التراجع عنه.</a:t>
-            </a:r>
-          </a:p>
-        </p:txBody>
-      </p:sp>
-      <p:sp>
-        <p:nvSpPr>
-          <p:cNvPr id="7" name="TextBox 6"/>
-          <p:cNvSpPr txBox="1"/>
-          <p:nvPr/>
-        </p:nvSpPr>
-        <p:spPr>
-          <a:xfrm>
-            <a:off x="540000" y="1744799"/>
-            <a:ext cx="11112119" cy="2202180"/>
-          </a:xfrm>
-          <a:prstGeom prst="rect">
-            <a:avLst/>
-          </a:prstGeom>
-          <a:noFill/>
-        </p:spPr>
-        <p:txBody>
-          <a:bodyPr wrap="square" lIns="36000" rIns="36000">
-            <a:spAutoFit/>
-          </a:bodyPr>
-          <a:lstStyle/>
-          <a:p>
-            <a:pPr algn="r" rtl="1">
-              <a:lnSpc>
-                <a:spcPct val="130000"/>
-              </a:lnSpc>
-            </a:pPr>
-            <a:r>
-              <a:rPr sz="1700" b="0">
-                <a:solidFill>
-                  <a:srgbClr val="22303F"/>
-                </a:solidFill>
-                <a:latin typeface="Cairo"/>
-                <a:cs typeface="Cairo"/>
-              </a:rPr>
-              <a:t>• المهمة 1: تثبيت Git والتحقق منه</a:t>
-            </a:r>
-          </a:p>
-          <a:p>
-            <a:pPr algn="r" rtl="1">
-              <a:lnSpc>
-                <a:spcPct val="130000"/>
-              </a:lnSpc>
-            </a:pPr>
-            <a:r>
-              <a:rPr sz="1700" b="0">
-                <a:solidFill>
-                  <a:srgbClr val="22303F"/>
-                </a:solidFill>
-                <a:latin typeface="Cairo"/>
-                <a:cs typeface="Cairo"/>
-              </a:rPr>
-              <a:t>• المهمة 2: ضبط الهوية (الاسم والبريد) — أهم خطوة في الورقة</a:t>
-            </a:r>
-          </a:p>
-          <a:p>
-            <a:pPr algn="r" rtl="1">
-              <a:lnSpc>
-                <a:spcPct val="130000"/>
-              </a:lnSpc>
-            </a:pPr>
-            <a:r>
-              <a:rPr sz="1700" b="0">
-                <a:solidFill>
-                  <a:srgbClr val="22303F"/>
-                </a:solidFill>
-                <a:latin typeface="Cairo"/>
-                <a:cs typeface="Cairo"/>
-              </a:rPr>
-              <a:t>• المهمة 3: إنشاء حساب GitHub مهني + التحقق بخطوتين</a:t>
-            </a:r>
-          </a:p>
-          <a:p>
-            <a:pPr algn="r" rtl="1">
-              <a:lnSpc>
-                <a:spcPct val="130000"/>
-              </a:lnSpc>
-            </a:pPr>
-            <a:r>
-              <a:rPr sz="1700" b="0">
-                <a:solidFill>
-                  <a:srgbClr val="22303F"/>
-                </a:solidFill>
-                <a:latin typeface="Cairo"/>
-                <a:cs typeface="Cairo"/>
-              </a:rPr>
-              <a:t>• المهمة 4: مفتاح SSH أو رمز وصول شخصي (PAT)</a:t>
-            </a:r>
-          </a:p>
-          <a:p>
-            <a:pPr algn="r" rtl="1">
-              <a:lnSpc>
-                <a:spcPct val="130000"/>
-              </a:lnSpc>
-            </a:pPr>
-            <a:r>
-              <a:rPr sz="1700" b="0">
-                <a:solidFill>
-                  <a:srgbClr val="22303F"/>
-                </a:solidFill>
-                <a:latin typeface="Cairo"/>
-                <a:cs typeface="Cairo"/>
-              </a:rPr>
-              <a:t>• المهمة 5: تجهيز VS Code والطرفية</a:t>
-            </a:r>
-          </a:p>
-          <a:p>
-            <a:pPr algn="r" rtl="1">
-              <a:lnSpc>
-                <a:spcPct val="130000"/>
-              </a:lnSpc>
-            </a:pPr>
-            <a:r>
-              <a:rPr sz="1700" b="0">
-                <a:solidFill>
-                  <a:srgbClr val="22303F"/>
-                </a:solidFill>
-                <a:latin typeface="Cairo"/>
-                <a:cs typeface="Cairo"/>
-              </a:rPr>
-              <a:t>• المهمة 6: أول مستودع شخصي: clone ثم commit ثم push</a:t>
             </a:r>
           </a:p>
         </p:txBody>

</xml_diff>

<commit_message>
feat(slides): deck PDFs + presenter notes
- tools/decks_to_pdf.mjs + build_slides_html.py --pdf → slides/pdf/*.pdf
  (one page per slide, 33.8×19 cm, page-size honoured via preferCSSPageSize)
- build_slides.py: :::notes blocks → PPTX speaker notes (presenter view);
  session brief (timing, objectives, focus points, board questions) added to
  the title slide of each of the six decks
- source/slides/README.md documents :::notes and the three output formats
- trainer guide checklist + README updated for PPTX/HTML/PDF delivery

Co-authored-by: arena-agent <297053741+arena-agent@users.noreply.github.com>
</commit_message>
<xml_diff>
--- a/slides/s1-intro.pptx
+++ b/slides/s1-intro.pptx
@@ -6,16 +6,16 @@
   </p:sldMasterIdLst>
   <p:sldIdLst>
     <p:sldId id="256" r:id="rId7"/>
-    <p:sldId id="257" r:id="rId8"/>
-    <p:sldId id="258" r:id="rId9"/>
-    <p:sldId id="259" r:id="rId10"/>
-    <p:sldId id="260" r:id="rId11"/>
-    <p:sldId id="261" r:id="rId12"/>
-    <p:sldId id="262" r:id="rId13"/>
-    <p:sldId id="263" r:id="rId14"/>
-    <p:sldId id="264" r:id="rId15"/>
-    <p:sldId id="265" r:id="rId16"/>
-    <p:sldId id="266" r:id="rId17"/>
+    <p:sldId id="257" r:id="rId9"/>
+    <p:sldId id="258" r:id="rId10"/>
+    <p:sldId id="259" r:id="rId11"/>
+    <p:sldId id="260" r:id="rId12"/>
+    <p:sldId id="261" r:id="rId13"/>
+    <p:sldId id="262" r:id="rId14"/>
+    <p:sldId id="263" r:id="rId15"/>
+    <p:sldId id="264" r:id="rId16"/>
+    <p:sldId id="265" r:id="rId17"/>
+    <p:sldId id="266" r:id="rId18"/>
   </p:sldIdLst>
   <p:sldSz cx="12192119" cy="6858000" type="screen4x3"/>
   <p:notesSz cx="6858000" cy="9144000"/>
@@ -115,6 +115,471 @@
     </a:lvl9pPr>
   </p:defaultTextStyle>
 </p:presentation>
+</file>
+
+<file path=ppt/notesMasters/notesMaster1.xml><?xml version="1.0" encoding="utf-8"?>
+<p:notesMaster xmlns:a="http://schemas.openxmlformats.org/drawingml/2006/main" xmlns:p="http://schemas.openxmlformats.org/presentationml/2006/main" xmlns:r="http://schemas.openxmlformats.org/officeDocument/2006/relationships">
+  <p:cSld>
+    <p:bg>
+      <p:bgRef idx="1001">
+        <a:schemeClr val="bg1"/>
+      </p:bgRef>
+    </p:bg>
+    <p:spTree>
+      <p:nvGrpSpPr>
+        <p:cNvPr id="1" name=""/>
+        <p:cNvGrpSpPr/>
+        <p:nvPr/>
+      </p:nvGrpSpPr>
+      <p:grpSpPr>
+        <a:xfrm>
+          <a:off x="0" y="0"/>
+          <a:ext cx="0" cy="0"/>
+          <a:chOff x="0" y="0"/>
+          <a:chExt cx="0" cy="0"/>
+        </a:xfrm>
+      </p:grpSpPr>
+      <p:sp>
+        <p:nvSpPr>
+          <p:cNvPr id="2" name="Header Placeholder 1"/>
+          <p:cNvSpPr>
+            <a:spLocks noGrp="1"/>
+          </p:cNvSpPr>
+          <p:nvPr>
+            <p:ph type="hdr" sz="quarter"/>
+          </p:nvPr>
+        </p:nvSpPr>
+        <p:spPr>
+          <a:xfrm>
+            <a:off x="0" y="0"/>
+            <a:ext cx="2971800" cy="457200"/>
+          </a:xfrm>
+          <a:prstGeom prst="rect">
+            <a:avLst/>
+          </a:prstGeom>
+        </p:spPr>
+        <p:txBody>
+          <a:bodyPr vert="horz" lIns="91440" tIns="45720" rIns="91440" bIns="45720" rtlCol="0"/>
+          <a:lstStyle>
+            <a:lvl1pPr algn="l">
+              <a:defRPr sz="1200"/>
+            </a:lvl1pPr>
+          </a:lstStyle>
+          <a:p>
+            <a:endParaRPr lang="en-US"/>
+          </a:p>
+        </p:txBody>
+      </p:sp>
+      <p:sp>
+        <p:nvSpPr>
+          <p:cNvPr id="3" name="Date Placeholder 2"/>
+          <p:cNvSpPr>
+            <a:spLocks noGrp="1"/>
+          </p:cNvSpPr>
+          <p:nvPr>
+            <p:ph type="dt" idx="1"/>
+          </p:nvPr>
+        </p:nvSpPr>
+        <p:spPr>
+          <a:xfrm>
+            <a:off x="3884613" y="0"/>
+            <a:ext cx="2971800" cy="457200"/>
+          </a:xfrm>
+          <a:prstGeom prst="rect">
+            <a:avLst/>
+          </a:prstGeom>
+        </p:spPr>
+        <p:txBody>
+          <a:bodyPr vert="horz" lIns="91440" tIns="45720" rIns="91440" bIns="45720" rtlCol="0"/>
+          <a:lstStyle>
+            <a:lvl1pPr algn="r">
+              <a:defRPr sz="1200"/>
+            </a:lvl1pPr>
+          </a:lstStyle>
+          <a:p>
+            <a:fld id="{0F89C1C7-3DCD-1040-A9CF-14679D8B5DDD}" type="datetimeFigureOut">
+              <a:rPr lang="en-US" smtClean="0"/>
+              <a:t>10/17/16</a:t>
+            </a:fld>
+            <a:endParaRPr lang="en-US"/>
+          </a:p>
+        </p:txBody>
+      </p:sp>
+      <p:sp>
+        <p:nvSpPr>
+          <p:cNvPr id="4" name="Slide Image Placeholder 3"/>
+          <p:cNvSpPr>
+            <a:spLocks noGrp="1" noRot="1" noChangeAspect="1"/>
+          </p:cNvSpPr>
+          <p:nvPr>
+            <p:ph type="sldImg" idx="2"/>
+          </p:nvPr>
+        </p:nvSpPr>
+        <p:spPr>
+          <a:xfrm>
+            <a:off x="1143000" y="685800"/>
+            <a:ext cx="4572000" cy="3429000"/>
+          </a:xfrm>
+          <a:prstGeom prst="rect">
+            <a:avLst/>
+          </a:prstGeom>
+          <a:noFill/>
+          <a:ln w="12700">
+            <a:solidFill>
+              <a:prstClr val="black"/>
+            </a:solidFill>
+          </a:ln>
+        </p:spPr>
+        <p:txBody>
+          <a:bodyPr vert="horz" lIns="91440" tIns="45720" rIns="91440" bIns="45720" rtlCol="0" anchor="ctr"/>
+          <a:lstStyle/>
+          <a:p>
+            <a:endParaRPr lang="en-US"/>
+          </a:p>
+        </p:txBody>
+      </p:sp>
+      <p:sp>
+        <p:nvSpPr>
+          <p:cNvPr id="5" name="Notes Placeholder 4"/>
+          <p:cNvSpPr>
+            <a:spLocks noGrp="1"/>
+          </p:cNvSpPr>
+          <p:nvPr>
+            <p:ph type="body" sz="quarter" idx="3"/>
+          </p:nvPr>
+        </p:nvSpPr>
+        <p:spPr>
+          <a:xfrm>
+            <a:off x="685800" y="4343400"/>
+            <a:ext cx="5486400" cy="4114800"/>
+          </a:xfrm>
+          <a:prstGeom prst="rect">
+            <a:avLst/>
+          </a:prstGeom>
+        </p:spPr>
+        <p:txBody>
+          <a:bodyPr vert="horz" lIns="91440" tIns="45720" rIns="91440" bIns="45720" rtlCol="0"/>
+          <a:lstStyle/>
+          <a:p>
+            <a:pPr lvl="0"/>
+            <a:r>
+              <a:rPr lang="en-US" smtClean="0"/>
+              <a:t>Click to edit Master text styles</a:t>
+            </a:r>
+          </a:p>
+          <a:p>
+            <a:pPr lvl="1"/>
+            <a:r>
+              <a:rPr lang="en-US" smtClean="0"/>
+              <a:t>Second level</a:t>
+            </a:r>
+          </a:p>
+          <a:p>
+            <a:pPr lvl="2"/>
+            <a:r>
+              <a:rPr lang="en-US" smtClean="0"/>
+              <a:t>Third level</a:t>
+            </a:r>
+          </a:p>
+          <a:p>
+            <a:pPr lvl="3"/>
+            <a:r>
+              <a:rPr lang="en-US" smtClean="0"/>
+              <a:t>Fourth level</a:t>
+            </a:r>
+          </a:p>
+          <a:p>
+            <a:pPr lvl="4"/>
+            <a:r>
+              <a:rPr lang="en-US" smtClean="0"/>
+              <a:t>Fifth level</a:t>
+            </a:r>
+            <a:endParaRPr lang="en-US"/>
+          </a:p>
+        </p:txBody>
+      </p:sp>
+      <p:sp>
+        <p:nvSpPr>
+          <p:cNvPr id="6" name="Footer Placeholder 5"/>
+          <p:cNvSpPr>
+            <a:spLocks noGrp="1"/>
+          </p:cNvSpPr>
+          <p:nvPr>
+            <p:ph type="ftr" sz="quarter" idx="4"/>
+          </p:nvPr>
+        </p:nvSpPr>
+        <p:spPr>
+          <a:xfrm>
+            <a:off x="0" y="8685213"/>
+            <a:ext cx="2971800" cy="457200"/>
+          </a:xfrm>
+          <a:prstGeom prst="rect">
+            <a:avLst/>
+          </a:prstGeom>
+        </p:spPr>
+        <p:txBody>
+          <a:bodyPr vert="horz" lIns="91440" tIns="45720" rIns="91440" bIns="45720" rtlCol="0" anchor="b"/>
+          <a:lstStyle>
+            <a:lvl1pPr algn="l">
+              <a:defRPr sz="1200"/>
+            </a:lvl1pPr>
+          </a:lstStyle>
+          <a:p>
+            <a:endParaRPr lang="en-US"/>
+          </a:p>
+        </p:txBody>
+      </p:sp>
+      <p:sp>
+        <p:nvSpPr>
+          <p:cNvPr id="7" name="Slide Number Placeholder 6"/>
+          <p:cNvSpPr>
+            <a:spLocks noGrp="1"/>
+          </p:cNvSpPr>
+          <p:nvPr>
+            <p:ph type="sldNum" sz="quarter" idx="5"/>
+          </p:nvPr>
+        </p:nvSpPr>
+        <p:spPr>
+          <a:xfrm>
+            <a:off x="3884613" y="8685213"/>
+            <a:ext cx="2971800" cy="457200"/>
+          </a:xfrm>
+          <a:prstGeom prst="rect">
+            <a:avLst/>
+          </a:prstGeom>
+        </p:spPr>
+        <p:txBody>
+          <a:bodyPr vert="horz" lIns="91440" tIns="45720" rIns="91440" bIns="45720" rtlCol="0" anchor="b"/>
+          <a:lstStyle>
+            <a:lvl1pPr algn="r">
+              <a:defRPr sz="1200"/>
+            </a:lvl1pPr>
+          </a:lstStyle>
+          <a:p>
+            <a:fld id="{BB5E49A5-4136-284D-997B-48E1D791AD67}" type="slidenum">
+              <a:rPr lang="en-US" smtClean="0"/>
+              <a:t>‹#›</a:t>
+            </a:fld>
+            <a:endParaRPr lang="en-US"/>
+          </a:p>
+        </p:txBody>
+      </p:sp>
+    </p:spTree>
+    <p:extLst>
+      <p:ext uri="{BB962C8B-B14F-4D97-AF65-F5344CB8AC3E}">
+        <p14:creationId xmlns:p14="http://schemas.microsoft.com/office/powerpoint/2010/main" val="2623252185"/>
+      </p:ext>
+    </p:extLst>
+  </p:cSld>
+  <p:clrMap bg1="lt1" tx1="dk1" bg2="lt2" tx2="dk2" accent1="accent1" accent2="accent2" accent3="accent3" accent4="accent4" accent5="accent5" accent6="accent6" hlink="hlink" folHlink="folHlink"/>
+  <p:notesStyle>
+    <a:lvl1pPr marL="0" algn="l" defTabSz="457200" rtl="0" eaLnBrk="1" latinLnBrk="0" hangingPunct="1">
+      <a:defRPr sz="1200" kern="1200">
+        <a:solidFill>
+          <a:schemeClr val="tx1"/>
+        </a:solidFill>
+        <a:latin typeface="+mn-lt"/>
+        <a:ea typeface="+mn-ea"/>
+        <a:cs typeface="+mn-cs"/>
+      </a:defRPr>
+    </a:lvl1pPr>
+    <a:lvl2pPr marL="457200" algn="l" defTabSz="457200" rtl="0" eaLnBrk="1" latinLnBrk="0" hangingPunct="1">
+      <a:defRPr sz="1200" kern="1200">
+        <a:solidFill>
+          <a:schemeClr val="tx1"/>
+        </a:solidFill>
+        <a:latin typeface="+mn-lt"/>
+        <a:ea typeface="+mn-ea"/>
+        <a:cs typeface="+mn-cs"/>
+      </a:defRPr>
+    </a:lvl2pPr>
+    <a:lvl3pPr marL="914400" algn="l" defTabSz="457200" rtl="0" eaLnBrk="1" latinLnBrk="0" hangingPunct="1">
+      <a:defRPr sz="1200" kern="1200">
+        <a:solidFill>
+          <a:schemeClr val="tx1"/>
+        </a:solidFill>
+        <a:latin typeface="+mn-lt"/>
+        <a:ea typeface="+mn-ea"/>
+        <a:cs typeface="+mn-cs"/>
+      </a:defRPr>
+    </a:lvl3pPr>
+    <a:lvl4pPr marL="1371600" algn="l" defTabSz="457200" rtl="0" eaLnBrk="1" latinLnBrk="0" hangingPunct="1">
+      <a:defRPr sz="1200" kern="1200">
+        <a:solidFill>
+          <a:schemeClr val="tx1"/>
+        </a:solidFill>
+        <a:latin typeface="+mn-lt"/>
+        <a:ea typeface="+mn-ea"/>
+        <a:cs typeface="+mn-cs"/>
+      </a:defRPr>
+    </a:lvl4pPr>
+    <a:lvl5pPr marL="1828800" algn="l" defTabSz="457200" rtl="0" eaLnBrk="1" latinLnBrk="0" hangingPunct="1">
+      <a:defRPr sz="1200" kern="1200">
+        <a:solidFill>
+          <a:schemeClr val="tx1"/>
+        </a:solidFill>
+        <a:latin typeface="+mn-lt"/>
+        <a:ea typeface="+mn-ea"/>
+        <a:cs typeface="+mn-cs"/>
+      </a:defRPr>
+    </a:lvl5pPr>
+    <a:lvl6pPr marL="2286000" algn="l" defTabSz="457200" rtl="0" eaLnBrk="1" latinLnBrk="0" hangingPunct="1">
+      <a:defRPr sz="1200" kern="1200">
+        <a:solidFill>
+          <a:schemeClr val="tx1"/>
+        </a:solidFill>
+        <a:latin typeface="+mn-lt"/>
+        <a:ea typeface="+mn-ea"/>
+        <a:cs typeface="+mn-cs"/>
+      </a:defRPr>
+    </a:lvl6pPr>
+    <a:lvl7pPr marL="2743200" algn="l" defTabSz="457200" rtl="0" eaLnBrk="1" latinLnBrk="0" hangingPunct="1">
+      <a:defRPr sz="1200" kern="1200">
+        <a:solidFill>
+          <a:schemeClr val="tx1"/>
+        </a:solidFill>
+        <a:latin typeface="+mn-lt"/>
+        <a:ea typeface="+mn-ea"/>
+        <a:cs typeface="+mn-cs"/>
+      </a:defRPr>
+    </a:lvl7pPr>
+    <a:lvl8pPr marL="3200400" algn="l" defTabSz="457200" rtl="0" eaLnBrk="1" latinLnBrk="0" hangingPunct="1">
+      <a:defRPr sz="1200" kern="1200">
+        <a:solidFill>
+          <a:schemeClr val="tx1"/>
+        </a:solidFill>
+        <a:latin typeface="+mn-lt"/>
+        <a:ea typeface="+mn-ea"/>
+        <a:cs typeface="+mn-cs"/>
+      </a:defRPr>
+    </a:lvl8pPr>
+    <a:lvl9pPr marL="3657600" algn="l" defTabSz="457200" rtl="0" eaLnBrk="1" latinLnBrk="0" hangingPunct="1">
+      <a:defRPr sz="1200" kern="1200">
+        <a:solidFill>
+          <a:schemeClr val="tx1"/>
+        </a:solidFill>
+        <a:latin typeface="+mn-lt"/>
+        <a:ea typeface="+mn-ea"/>
+        <a:cs typeface="+mn-cs"/>
+      </a:defRPr>
+    </a:lvl9pPr>
+  </p:notesStyle>
+</p:notesMaster>
+</file>
+
+<file path=ppt/notesSlides/notesSlide1.xml><?xml version="1.0" encoding="utf-8"?>
+<p:notes xmlns:a="http://schemas.openxmlformats.org/drawingml/2006/main" xmlns:p="http://schemas.openxmlformats.org/presentationml/2006/main" xmlns:r="http://schemas.openxmlformats.org/officeDocument/2006/relationships">
+  <p:cSld>
+    <p:spTree>
+      <p:nvGrpSpPr>
+        <p:cNvPr id="1" name=""/>
+        <p:cNvGrpSpPr/>
+        <p:nvPr/>
+      </p:nvGrpSpPr>
+      <p:grpSpPr>
+        <a:xfrm>
+          <a:off x="0" y="0"/>
+          <a:ext cx="0" cy="0"/>
+          <a:chOff x="0" y="0"/>
+          <a:chExt cx="0" cy="0"/>
+        </a:xfrm>
+      </p:grpSpPr>
+      <p:sp>
+        <p:nvSpPr>
+          <p:cNvPr id="2" name="Slide Image Placeholder 1"/>
+          <p:cNvSpPr>
+            <a:spLocks noGrp="1"/>
+          </p:cNvSpPr>
+          <p:nvPr>
+            <p:ph type="sldImg" idx="2"/>
+          </p:nvPr>
+        </p:nvSpPr>
+        <p:spPr/>
+      </p:sp>
+      <p:sp>
+        <p:nvSpPr>
+          <p:cNvPr id="3" name="Notes Placeholder 2"/>
+          <p:cNvSpPr>
+            <a:spLocks noGrp="1"/>
+          </p:cNvSpPr>
+          <p:nvPr>
+            <p:ph type="body" idx="3" sz="quarter"/>
+          </p:nvPr>
+        </p:nvSpPr>
+        <p:spPr/>
+        <p:txBody>
+          <a:bodyPr/>
+          <a:lstStyle/>
+          <a:p>
+            <a:pPr algn="r" rtl="1"/>
+            <a:r>
+              <a:rPr sz="1400">
+                <a:latin typeface="Cairo"/>
+                <a:cs typeface="Cairo"/>
+              </a:rPr>
+              <a:t>الزمن: عرض 20 د — ثم تنفيذ 60 د — تحقّق 10 د.</a:t>
+            </a:r>
+          </a:p>
+          <a:p>
+            <a:pPr algn="r" rtl="1"/>
+            <a:r>
+              <a:rPr sz="1400">
+                <a:latin typeface="Cairo"/>
+                <a:cs typeface="Cairo"/>
+              </a:rPr>
+              <a:t>الهدف: أن يخرج كل متدرّب من الجلسة بحساب مؤمَّن + Git مهيّأ ببريده + مستودع شخصي فيه التزامه الأول.</a:t>
+            </a:r>
+          </a:p>
+          <a:p>
+            <a:pPr algn="r" rtl="1"/>
+            <a:r>
+              <a:rPr sz="1400">
+                <a:latin typeface="Cairo"/>
+                <a:cs typeface="Cairo"/>
+              </a:rPr>
+              <a:t>نقاط التركيز: (1) الفرق بين Git وGitHub — أكثر خطأ مفهومي في البداية. (2) بريد git config يجب أن يطابق بريد حساب GitHub. (3) 2FA إلزامي.</a:t>
+            </a:r>
+          </a:p>
+          <a:p>
+            <a:pPr algn="r" rtl="1"/>
+            <a:r>
+              <a:rPr sz="1400">
+                <a:latin typeface="Cairo"/>
+                <a:cs typeface="Cairo"/>
+              </a:rPr>
+              <a:t>اسأل الفصل: «أين يعمل git status؟ وأين يعمل git push؟» — يثبّت الفرق بين المحلي والخادم.</a:t>
+            </a:r>
+          </a:p>
+          <a:p>
+            <a:pPr algn="r" rtl="1"/>
+            <a:r>
+              <a:rPr sz="1400">
+                <a:latin typeface="Cairo"/>
+                <a:cs typeface="Cairo"/>
+              </a:rPr>
+              <a:t>تحقّق ختامي: git config --list + git log --oneline على جهاز كل متدرّب قبل المغادرة.</a:t>
+            </a:r>
+          </a:p>
+        </p:txBody>
+      </p:sp>
+      <p:sp>
+        <p:nvSpPr>
+          <p:cNvPr id="4" name="Slide Number Placeholder 3"/>
+          <p:cNvSpPr>
+            <a:spLocks noGrp="1"/>
+          </p:cNvSpPr>
+          <p:nvPr>
+            <p:ph type="sldNum" idx="5" sz="quarter"/>
+          </p:nvPr>
+        </p:nvSpPr>
+        <p:spPr/>
+      </p:sp>
+    </p:spTree>
+  </p:cSld>
+  <p:clrMapOvr>
+    <a:masterClrMapping/>
+  </p:clrMapOvr>
+</p:notes>
 </file>
 
 <file path=ppt/slideLayouts/slideLayout1.xml><?xml version="1.0" encoding="utf-8"?>
@@ -7236,4 +7701,324 @@
   </a:objectDefaults>
   <a:extraClrSchemeLst/>
 </a:theme>
+</file>
+
+<file path=ppt/theme/theme2.xml><?xml version="1.0" encoding="utf-8"?>
+<a:theme xmlns:a="http://schemas.openxmlformats.org/drawingml/2006/main" name="Office Theme">
+  <a:themeElements>
+    <a:clrScheme name="Office">
+      <a:dk1>
+        <a:sysClr val="windowText" lastClr="000000"/>
+      </a:dk1>
+      <a:lt1>
+        <a:sysClr val="window" lastClr="FFFFFF"/>
+      </a:lt1>
+      <a:dk2>
+        <a:srgbClr val="1F497D"/>
+      </a:dk2>
+      <a:lt2>
+        <a:srgbClr val="EEECE1"/>
+      </a:lt2>
+      <a:accent1>
+        <a:srgbClr val="4F81BD"/>
+      </a:accent1>
+      <a:accent2>
+        <a:srgbClr val="C0504D"/>
+      </a:accent2>
+      <a:accent3>
+        <a:srgbClr val="9BBB59"/>
+      </a:accent3>
+      <a:accent4>
+        <a:srgbClr val="8064A2"/>
+      </a:accent4>
+      <a:accent5>
+        <a:srgbClr val="4BACC6"/>
+      </a:accent5>
+      <a:accent6>
+        <a:srgbClr val="F79646"/>
+      </a:accent6>
+      <a:hlink>
+        <a:srgbClr val="0000FF"/>
+      </a:hlink>
+      <a:folHlink>
+        <a:srgbClr val="800080"/>
+      </a:folHlink>
+    </a:clrScheme>
+    <a:fontScheme name="Office">
+      <a:majorFont>
+        <a:latin typeface="Calibri"/>
+        <a:ea typeface=""/>
+        <a:cs typeface=""/>
+        <a:font script="Jpan" typeface="ＭＳ Ｐゴシック"/>
+        <a:font script="Hang" typeface="맑은 고딕"/>
+        <a:font script="Hans" typeface="宋体"/>
+        <a:font script="Hant" typeface="新細明體"/>
+        <a:font script="Arab" typeface="Times New Roman"/>
+        <a:font script="Hebr" typeface="Times New Roman"/>
+        <a:font script="Thai" typeface="Angsana New"/>
+        <a:font script="Ethi" typeface="Nyala"/>
+        <a:font script="Beng" typeface="Vrinda"/>
+        <a:font script="Gujr" typeface="Shruti"/>
+        <a:font script="Khmr" typeface="MoolBoran"/>
+        <a:font script="Knda" typeface="Tunga"/>
+        <a:font script="Guru" typeface="Raavi"/>
+        <a:font script="Cans" typeface="Euphemia"/>
+        <a:font script="Cher" typeface="Plantagenet Cherokee"/>
+        <a:font script="Yiii" typeface="Microsoft Yi Baiti"/>
+        <a:font script="Tibt" typeface="Microsoft Himalaya"/>
+        <a:font script="Thaa" typeface="MV Boli"/>
+        <a:font script="Deva" typeface="Mangal"/>
+        <a:font script="Telu" typeface="Gautami"/>
+        <a:font script="Taml" typeface="Latha"/>
+        <a:font script="Syrc" typeface="Estrangelo Edessa"/>
+        <a:font script="Orya" typeface="Kalinga"/>
+        <a:font script="Mlym" typeface="Kartika"/>
+        <a:font script="Laoo" typeface="DokChampa"/>
+        <a:font script="Sinh" typeface="Iskoola Pota"/>
+        <a:font script="Mong" typeface="Mongolian Baiti"/>
+        <a:font script="Viet" typeface="Times New Roman"/>
+        <a:font script="Uigh" typeface="Microsoft Uighur"/>
+        <a:font script="Geor" typeface="Sylfaen"/>
+      </a:majorFont>
+      <a:minorFont>
+        <a:latin typeface="Calibri"/>
+        <a:ea typeface=""/>
+        <a:cs typeface=""/>
+        <a:font script="Jpan" typeface="ＭＳ Ｐゴシック"/>
+        <a:font script="Hang" typeface="맑은 고딕"/>
+        <a:font script="Hans" typeface="宋体"/>
+        <a:font script="Hant" typeface="新細明體"/>
+        <a:font script="Arab" typeface="Arial"/>
+        <a:font script="Hebr" typeface="Arial"/>
+        <a:font script="Thai" typeface="Cordia New"/>
+        <a:font script="Ethi" typeface="Nyala"/>
+        <a:font script="Beng" typeface="Vrinda"/>
+        <a:font script="Gujr" typeface="Shruti"/>
+        <a:font script="Khmr" typeface="DaunPenh"/>
+        <a:font script="Knda" typeface="Tunga"/>
+        <a:font script="Guru" typeface="Raavi"/>
+        <a:font script="Cans" typeface="Euphemia"/>
+        <a:font script="Cher" typeface="Plantagenet Cherokee"/>
+        <a:font script="Yiii" typeface="Microsoft Yi Baiti"/>
+        <a:font script="Tibt" typeface="Microsoft Himalaya"/>
+        <a:font script="Thaa" typeface="MV Boli"/>
+        <a:font script="Deva" typeface="Mangal"/>
+        <a:font script="Telu" typeface="Gautami"/>
+        <a:font script="Taml" typeface="Latha"/>
+        <a:font script="Syrc" typeface="Estrangelo Edessa"/>
+        <a:font script="Orya" typeface="Kalinga"/>
+        <a:font script="Mlym" typeface="Kartika"/>
+        <a:font script="Laoo" typeface="DokChampa"/>
+        <a:font script="Sinh" typeface="Iskoola Pota"/>
+        <a:font script="Mong" typeface="Mongolian Baiti"/>
+        <a:font script="Viet" typeface="Arial"/>
+        <a:font script="Uigh" typeface="Microsoft Uighur"/>
+        <a:font script="Geor" typeface="Sylfaen"/>
+      </a:minorFont>
+    </a:fontScheme>
+    <a:fmtScheme name="Office">
+      <a:fillStyleLst>
+        <a:solidFill>
+          <a:schemeClr val="phClr"/>
+        </a:solidFill>
+        <a:gradFill rotWithShape="1">
+          <a:gsLst>
+            <a:gs pos="0">
+              <a:schemeClr val="phClr">
+                <a:tint val="50000"/>
+                <a:satMod val="300000"/>
+              </a:schemeClr>
+            </a:gs>
+            <a:gs pos="35000">
+              <a:schemeClr val="phClr">
+                <a:tint val="37000"/>
+                <a:satMod val="300000"/>
+              </a:schemeClr>
+            </a:gs>
+            <a:gs pos="100000">
+              <a:schemeClr val="phClr">
+                <a:tint val="15000"/>
+                <a:satMod val="350000"/>
+              </a:schemeClr>
+            </a:gs>
+          </a:gsLst>
+          <a:lin ang="16200000" scaled="1"/>
+        </a:gradFill>
+        <a:gradFill rotWithShape="1">
+          <a:gsLst>
+            <a:gs pos="0">
+              <a:schemeClr val="phClr">
+                <a:tint val="100000"/>
+                <a:shade val="100000"/>
+                <a:satMod val="130000"/>
+              </a:schemeClr>
+            </a:gs>
+            <a:gs pos="100000">
+              <a:schemeClr val="phClr">
+                <a:tint val="50000"/>
+                <a:shade val="100000"/>
+                <a:satMod val="350000"/>
+              </a:schemeClr>
+            </a:gs>
+          </a:gsLst>
+          <a:lin ang="16200000" scaled="0"/>
+        </a:gradFill>
+      </a:fillStyleLst>
+      <a:lnStyleLst>
+        <a:ln w="9525" cap="flat" cmpd="sng" algn="ctr">
+          <a:solidFill>
+            <a:schemeClr val="phClr">
+              <a:shade val="95000"/>
+              <a:satMod val="105000"/>
+            </a:schemeClr>
+          </a:solidFill>
+          <a:prstDash val="solid"/>
+        </a:ln>
+        <a:ln w="25400" cap="flat" cmpd="sng" algn="ctr">
+          <a:solidFill>
+            <a:schemeClr val="phClr"/>
+          </a:solidFill>
+          <a:prstDash val="solid"/>
+        </a:ln>
+        <a:ln w="38100" cap="flat" cmpd="sng" algn="ctr">
+          <a:solidFill>
+            <a:schemeClr val="phClr"/>
+          </a:solidFill>
+          <a:prstDash val="solid"/>
+        </a:ln>
+      </a:lnStyleLst>
+      <a:effectStyleLst>
+        <a:effectStyle>
+          <a:effectLst>
+            <a:outerShdw blurRad="40000" dist="20000" dir="5400000" rotWithShape="0">
+              <a:srgbClr val="000000">
+                <a:alpha val="38000"/>
+              </a:srgbClr>
+            </a:outerShdw>
+          </a:effectLst>
+        </a:effectStyle>
+        <a:effectStyle>
+          <a:effectLst>
+            <a:outerShdw blurRad="40000" dist="23000" dir="5400000" rotWithShape="0">
+              <a:srgbClr val="000000">
+                <a:alpha val="35000"/>
+              </a:srgbClr>
+            </a:outerShdw>
+          </a:effectLst>
+        </a:effectStyle>
+        <a:effectStyle>
+          <a:effectLst>
+            <a:outerShdw blurRad="40000" dist="23000" dir="5400000" rotWithShape="0">
+              <a:srgbClr val="000000">
+                <a:alpha val="35000"/>
+              </a:srgbClr>
+            </a:outerShdw>
+          </a:effectLst>
+          <a:scene3d>
+            <a:camera prst="orthographicFront">
+              <a:rot lat="0" lon="0" rev="0"/>
+            </a:camera>
+            <a:lightRig rig="threePt" dir="t">
+              <a:rot lat="0" lon="0" rev="1200000"/>
+            </a:lightRig>
+          </a:scene3d>
+          <a:sp3d>
+            <a:bevelT w="63500" h="25400"/>
+          </a:sp3d>
+        </a:effectStyle>
+      </a:effectStyleLst>
+      <a:bgFillStyleLst>
+        <a:solidFill>
+          <a:schemeClr val="phClr"/>
+        </a:solidFill>
+        <a:gradFill rotWithShape="1">
+          <a:gsLst>
+            <a:gs pos="0">
+              <a:schemeClr val="phClr">
+                <a:tint val="40000"/>
+                <a:satMod val="350000"/>
+              </a:schemeClr>
+            </a:gs>
+            <a:gs pos="40000">
+              <a:schemeClr val="phClr">
+                <a:tint val="45000"/>
+                <a:shade val="99000"/>
+                <a:satMod val="350000"/>
+              </a:schemeClr>
+            </a:gs>
+            <a:gs pos="100000">
+              <a:schemeClr val="phClr">
+                <a:shade val="20000"/>
+                <a:satMod val="255000"/>
+              </a:schemeClr>
+            </a:gs>
+          </a:gsLst>
+          <a:path path="circle">
+            <a:fillToRect l="50000" t="-80000" r="50000" b="180000"/>
+          </a:path>
+        </a:gradFill>
+        <a:gradFill rotWithShape="1">
+          <a:gsLst>
+            <a:gs pos="0">
+              <a:schemeClr val="phClr">
+                <a:tint val="80000"/>
+                <a:satMod val="300000"/>
+              </a:schemeClr>
+            </a:gs>
+            <a:gs pos="100000">
+              <a:schemeClr val="phClr">
+                <a:shade val="30000"/>
+                <a:satMod val="200000"/>
+              </a:schemeClr>
+            </a:gs>
+          </a:gsLst>
+          <a:path path="circle">
+            <a:fillToRect l="50000" t="50000" r="50000" b="50000"/>
+          </a:path>
+        </a:gradFill>
+      </a:bgFillStyleLst>
+    </a:fmtScheme>
+  </a:themeElements>
+  <a:objectDefaults>
+    <a:spDef>
+      <a:spPr/>
+      <a:bodyPr/>
+      <a:lstStyle/>
+      <a:style>
+        <a:lnRef idx="1">
+          <a:schemeClr val="accent1"/>
+        </a:lnRef>
+        <a:fillRef idx="3">
+          <a:schemeClr val="accent1"/>
+        </a:fillRef>
+        <a:effectRef idx="2">
+          <a:schemeClr val="accent1"/>
+        </a:effectRef>
+        <a:fontRef idx="minor">
+          <a:schemeClr val="lt1"/>
+        </a:fontRef>
+      </a:style>
+    </a:spDef>
+    <a:lnDef>
+      <a:spPr/>
+      <a:bodyPr/>
+      <a:lstStyle/>
+      <a:style>
+        <a:lnRef idx="2">
+          <a:schemeClr val="accent1"/>
+        </a:lnRef>
+        <a:fillRef idx="0">
+          <a:schemeClr val="accent1"/>
+        </a:fillRef>
+        <a:effectRef idx="1">
+          <a:schemeClr val="accent1"/>
+        </a:effectRef>
+        <a:fontRef idx="minor">
+          <a:schemeClr val="tx1"/>
+        </a:fontRef>
+      </a:style>
+    </a:lnDef>
+  </a:objectDefaults>
+  <a:extraClrSchemeLst/>
+</a:theme>
 </file>
</xml_diff>